<commit_message>
Voice AI slide: value of missed transfers (half x average CP gross per RO)
Co-Authored-By: Claude Opus 5.5 <noreply@anthropic.com>
Claude-Session: https://claude.ai/code/session_01Xa4nFVxuQGXmHARGph9WhS
</commit_message>
<xml_diff>
--- a/day2-deck/decks/Voice AI - Flai.pptx
+++ b/day2-deck/decks/Voice AI - Flai.pptx
@@ -503,7 +503,7 @@
           <a:p>
             <a:r>
               <a:rPr lang="en-US" dirty="0"/>
-              <a:t>Source: Flai voice AI dashboard, Service view, standings export, Jul 26 - Oct 26, 2026 (93 days). Flai's location names (26 with calls). Pickup rate and resolution as Flai reports them. Flai's estimated savings, revenue and profit are not used. Handled by the AI alone = calls - transfers (the export has no separate column for it). Not picked up = transfers x (1 - pickup rate), from Flai's group figures.</a:t>
+              <a:t>Source: Flai voice AI dashboard, Service view, standings export, Jul 26 - Oct 26, 2026 (93 days). Flai's location names (26 with calls). Pickup rate and resolution as Flai reports them. Flai's estimated savings, revenue and profit are not used. Handled by the AI alone = calls - transfers (the export has no separate column for it). Not picked up = transfers x (1 - pickup rate), from Flai's group figures. Value: half of the missed transfers x $${gpr.toFixed(2)} average customer-pay gross per RO (Qlik - Closed Repair Orders, labor + parts gross, Jan-Sep 2026, same-store) = $${fmt(missedVal)}.</a:t>
             </a:r>
             <a:endParaRPr lang="en-US" dirty="0"/>
           </a:p>
@@ -1713,7 +1713,7 @@
                 <a:ea typeface="Inter" pitchFamily="34" charset="-122"/>
                 <a:cs typeface="Inter" pitchFamily="34" charset="-120"/>
               </a:rPr>
-              <a:t>About 13,710 transferred calls were not picked up by a person.</a:t>
+              <a:t>About 13,710 transfers missed. If half wanted an appointment, that is $2.3M of gross profit.</a:t>
             </a:r>
             <a:endParaRPr lang="en-US" sz="1400" dirty="0"/>
           </a:p>

</xml_diff>

<commit_message>
Voice AI slide: missed-call value includes warranty gross; source line fixed; average call time dropped
Co-Authored-By: Claude Opus 5.5 <noreply@anthropic.com>
Claude-Session: https://claude.ai/code/session_01Xa4nFVxuQGXmHARGph9WhS
</commit_message>
<xml_diff>
--- a/day2-deck/decks/Voice AI - Flai.pptx
+++ b/day2-deck/decks/Voice AI - Flai.pptx
@@ -503,7 +503,7 @@
           <a:p>
             <a:r>
               <a:rPr lang="en-US" dirty="0"/>
-              <a:t>Source: Flai voice AI dashboard, Service view, standings export, Jul 26 - Oct 26, 2026 (93 days). Flai's location names (26 with calls). Pickup rate and resolution as Flai reports them. Flai's estimated savings, revenue and profit are not used. Handled by the AI alone = calls - transfers (the export has no separate column for it). Not picked up = transfers x (1 - pickup rate), from Flai's group figures. Value: half of the missed transfers x $${gpr.toFixed(2)} average customer-pay gross per RO (Qlik - Closed Repair Orders, labor + parts gross, Jan-Sep 2026, same-store) = $${fmt(missedVal)}.</a:t>
+              <a:t>Source: Flai voice AI dashboard, Service view, standings export, Jul 26 - Oct 26, 2026 (93 days). Flai's location names (26 with calls). Pickup rate and resolution as Flai reports them. Flai's estimated savings, revenue and profit are not used. Handled by the AI alone = calls - transfers (the export has no separate column for it). Not picked up = transfers x (1 - pickup rate), from Flai's group figures. Value: half of the missed transfers x $384.67 average gross per customer-pay or warranty RO (CP labor + parts gross $95.7M, Qlik Closed ROs, plus warranty gross $47.1M, P&amp;L, over 371,180 CP &amp; W ROs, Jan-Sep 2026, same-store) = $2,636,879.</a:t>
             </a:r>
             <a:endParaRPr lang="en-US" dirty="0"/>
           </a:p>
@@ -1236,7 +1236,7 @@
                 <a:ea typeface="Inter" pitchFamily="34" charset="-122"/>
                 <a:cs typeface="Inter" pitchFamily="34" charset="-120"/>
               </a:rPr>
-              <a:t>About 526 a day across 26 locations, average call 1:49.</a:t>
+              <a:t>About 526 a day across 26 locations.</a:t>
             </a:r>
             <a:endParaRPr lang="en-US" sz="1400" dirty="0"/>
           </a:p>
@@ -1713,7 +1713,7 @@
                 <a:ea typeface="Inter" pitchFamily="34" charset="-122"/>
                 <a:cs typeface="Inter" pitchFamily="34" charset="-120"/>
               </a:rPr>
-              <a:t>About 13,710 transfers missed. If half wanted an appointment, that is $2.3M of gross profit.</a:t>
+              <a:t>About 13,710 transfers missed. If half wanted an appointment, that is $2.6M of gross profit.</a:t>
             </a:r>
             <a:endParaRPr lang="en-US" sz="1400" dirty="0"/>
           </a:p>

</xml_diff>